<commit_message>
docs(submissions): align the Demo Labs materials with the 0.3.0 TUI (#154)
The runbook, the talk script and slide 24 of the deck all described a single
command bar -- o c i f g a d s l ? q w -- which 0.2.0 replaced with a two-layer
surface: a Simple Operator home screen and Expert controls behind e. Run as
written, Step 1 pressed c and Step 2 pressed f on a screen that binds neither,
and slide 24 would have projected a key bar the audience could see did not match
the terminal beside it. Step 6, the climax, still had the Silent Standby key as
an unfilled blank.

Every value was read off the running application on a Pi Zero 2 W at c74d17f:
the home footer, the expert footer, Ctrl+S for Silent Standby with Ctrl+R or Esc
to recover and no footer entry, and w as an app-level binding. The sequence is
now n -> e -> f -> g -> a -> w -> Ctrl+S.

The deck was edited by string replacement on two package entries with no XML
parser involved; the other 231 entries are byte-identical.
</commit_message>
<xml_diff>
--- a/docs/submissions/Phasmid_DEFCON_DemoLabs.pptx
+++ b/docs/submissions/Phasmid_DEFCON_DemoLabs.pptx
@@ -1968,8 +1968,8 @@
             <a:r>
               <a:rPr lang="en-US" dirty="0"/>
               <a:t>[19:20 / ~7:00] LIVE DEMO  ★中心
-EN (最小限・手を動かしながら): "This is the real TUI — Local Disclosure Control. I'll create a vessel, set the object cue under Faces, run the Guided flow, check dummy-profile plausibility in Audit, launch the local WebUI, then trigger Silent Standby and show the dummy disclosure. Watch the bottom bar."
-JA デモ詳細は別ランブック参照（Phasmid_Demo_Runbook）。要点: 話しすぎない/画面を指す/各ステップで一呼吸。失敗時は録画へ切替し設計点を口頭補強。約7分で切り上げ、Q&amp;Aに15分残す。</a:t>
+EN (最小限・手を動かしながら): "This is the real TUI — Local Disclosure Control. The home screen is deliberately small — four actions, nothing else. Under pressure you do not want a wall of options. I'll create protected storage, then open Expert controls with one key: set the object cue under Faces, run the Guided flow, check dummy-profile plausibility in Audit, launch the local WebUI, then trigger Silent Standby and show the dummy disclosure."
+JA デモ詳細は別ランブック参照（Phasmid_Demo_Runbook）。キー順（0.3.0 実機確認済）: n New → e Expert → f Faces → g Guided → a Audit → w WebUI → Ctrl+S Silent Standby（復帰 Ctrl+R / Esc）。Ctrl+S はフッタに出ないので指で覚える。要点: 話しすぎない/画面を指す/各ステップで一呼吸。失敗時は録画へ切替し設計点を口頭補強。約7分で切り上げ、Q&amp;Aに15分残す。</a:t>
             </a:r>
             <a:endParaRPr lang="en-US" dirty="0"/>
           </a:p>
@@ -19185,7 +19185,7 @@
                 <a:ea typeface="Courier New" pitchFamily="34" charset="-122"/>
                 <a:cs typeface="Courier New" pitchFamily="34" charset="-120"/>
               </a:rPr>
-              <a:t>bottom bar  </a:t>
+              <a:t>home bar  </a:t>
             </a:r>
             <a:pPr indent="0" marL="0">
               <a:buNone/>
@@ -19199,7 +19199,7 @@
                 <a:ea typeface="Courier New" pitchFamily="34" charset="-122"/>
                 <a:cs typeface="Courier New" pitchFamily="34" charset="-120"/>
               </a:rPr>
-              <a:t>Open · Create · Faces · Guided · Audit · Doctor · LUKS · WebUI</a:t>
+              <a:t>Open · New · Guided · Expert · WebUI  ·  e → Create · Faces · Audit</a:t>
             </a:r>
             <a:endParaRPr lang="en-US" sz="1250" dirty="0"/>
           </a:p>

</xml_diff>

<commit_message>
docs: drop the corporate suffix from the affiliation
Confirmed by the presenter: the name is written "GMO Cybersecurity by
Ierae", with no "Inc." after it. Corrected on the title slide, the whoami
slide, the closing footer and the 30-minute script; the spoken lines and
the run-of-show already read it that way.

Co-Authored-By: Claude Opus 5 <noreply@anthropic.com>
Claude-Session: https://claude.ai/code/session_01Lx4dCiPgkqtC2b17GtDU6z
</commit_message>
<xml_diff>
--- a/docs/submissions/Phasmid_DEFCON_DemoLabs.pptx
+++ b/docs/submissions/Phasmid_DEFCON_DemoLabs.pptx
@@ -10129,6 +10129,10 @@
             <a:prstDash val="solid"/>
           </a:ln>
         </p:spPr>
+        <p:txBody>
+          <a:bodyPr/>
+          <a:p/>
+        </p:txBody>
       </p:sp>
       <p:sp>
         <p:nvSpPr>
@@ -10177,7 +10181,7 @@
                 <a:ea typeface="Courier New" pitchFamily="34" charset="-122"/>
                 <a:cs typeface="Courier New" pitchFamily="34" charset="-120"/>
               </a:rPr>
-              <a:t>  ·  Senior Engineer, GMO Cybersecurity by Ierae, Inc.</a:t>
+              <a:t>  ·  Senior Engineer, GMO Cybersecurity by Ierae</a:t>
             </a:r>
             <a:pPr algn="ctr" indent="0" marL="0">
               <a:buNone/>
@@ -10452,6 +10456,10 @@
             </a:outerShdw>
           </a:effectLst>
         </p:spPr>
+        <p:txBody>
+          <a:bodyPr/>
+          <a:p/>
+        </p:txBody>
       </p:sp>
       <p:sp>
         <p:nvSpPr>
@@ -10479,6 +10487,10 @@
             <a:prstDash val="solid"/>
           </a:ln>
         </p:spPr>
+        <p:txBody>
+          <a:bodyPr/>
+          <a:p/>
+        </p:txBody>
       </p:sp>
       <p:pic>
         <p:nvPicPr>
@@ -10618,6 +10630,10 @@
             </a:outerShdw>
           </a:effectLst>
         </p:spPr>
+        <p:txBody>
+          <a:bodyPr/>
+          <a:p/>
+        </p:txBody>
       </p:sp>
       <p:sp>
         <p:nvSpPr>
@@ -10645,6 +10661,10 @@
             <a:prstDash val="solid"/>
           </a:ln>
         </p:spPr>
+        <p:txBody>
+          <a:bodyPr/>
+          <a:p/>
+        </p:txBody>
       </p:sp>
       <p:pic>
         <p:nvPicPr>
@@ -10784,6 +10804,10 @@
             </a:outerShdw>
           </a:effectLst>
         </p:spPr>
+        <p:txBody>
+          <a:bodyPr/>
+          <a:p/>
+        </p:txBody>
       </p:sp>
       <p:sp>
         <p:nvSpPr>
@@ -10811,6 +10835,10 @@
             <a:prstDash val="solid"/>
           </a:ln>
         </p:spPr>
+        <p:txBody>
+          <a:bodyPr/>
+          <a:p/>
+        </p:txBody>
       </p:sp>
       <p:pic>
         <p:nvPicPr>
@@ -10950,6 +10978,10 @@
             </a:outerShdw>
           </a:effectLst>
         </p:spPr>
+        <p:txBody>
+          <a:bodyPr/>
+          <a:p/>
+        </p:txBody>
       </p:sp>
       <p:sp>
         <p:nvSpPr>
@@ -10977,6 +11009,10 @@
             <a:prstDash val="solid"/>
           </a:ln>
         </p:spPr>
+        <p:txBody>
+          <a:bodyPr/>
+          <a:p/>
+        </p:txBody>
       </p:sp>
       <p:pic>
         <p:nvPicPr>
@@ -11332,6 +11368,10 @@
             </a:outerShdw>
           </a:effectLst>
         </p:spPr>
+        <p:txBody>
+          <a:bodyPr/>
+          <a:p/>
+        </p:txBody>
       </p:sp>
       <p:pic>
         <p:nvPicPr>
@@ -11834,6 +11874,10 @@
             </a:outerShdw>
           </a:effectLst>
         </p:spPr>
+        <p:txBody>
+          <a:bodyPr/>
+          <a:p/>
+        </p:txBody>
       </p:sp>
       <p:pic>
         <p:nvPicPr>
@@ -12537,6 +12581,10 @@
             </a:outerShdw>
           </a:effectLst>
         </p:spPr>
+        <p:txBody>
+          <a:bodyPr/>
+          <a:p/>
+        </p:txBody>
       </p:sp>
       <p:sp>
         <p:nvSpPr>
@@ -12562,6 +12610,10 @@
             <a:prstDash val="solid"/>
           </a:ln>
         </p:spPr>
+        <p:txBody>
+          <a:bodyPr/>
+          <a:p/>
+        </p:txBody>
       </p:sp>
       <p:pic>
         <p:nvPicPr>
@@ -12701,6 +12753,10 @@
             </a:outerShdw>
           </a:effectLst>
         </p:spPr>
+        <p:txBody>
+          <a:bodyPr/>
+          <a:p/>
+        </p:txBody>
       </p:sp>
       <p:sp>
         <p:nvSpPr>
@@ -12726,6 +12782,10 @@
             <a:prstDash val="solid"/>
           </a:ln>
         </p:spPr>
+        <p:txBody>
+          <a:bodyPr/>
+          <a:p/>
+        </p:txBody>
       </p:sp>
       <p:pic>
         <p:nvPicPr>
@@ -12865,6 +12925,10 @@
             </a:outerShdw>
           </a:effectLst>
         </p:spPr>
+        <p:txBody>
+          <a:bodyPr/>
+          <a:p/>
+        </p:txBody>
       </p:sp>
       <p:sp>
         <p:nvSpPr>
@@ -12890,6 +12954,10 @@
             <a:prstDash val="solid"/>
           </a:ln>
         </p:spPr>
+        <p:txBody>
+          <a:bodyPr/>
+          <a:p/>
+        </p:txBody>
       </p:sp>
       <p:pic>
         <p:nvPicPr>
@@ -13245,6 +13313,10 @@
             </a:outerShdw>
           </a:effectLst>
         </p:spPr>
+        <p:txBody>
+          <a:bodyPr/>
+          <a:p/>
+        </p:txBody>
       </p:sp>
       <p:pic>
         <p:nvPicPr>
@@ -13387,6 +13459,10 @@
             </a:outerShdw>
           </a:effectLst>
         </p:spPr>
+        <p:txBody>
+          <a:bodyPr/>
+          <a:p/>
+        </p:txBody>
       </p:sp>
       <p:sp>
         <p:nvSpPr>
@@ -13638,6 +13714,10 @@
             <a:prstDash val="solid"/>
           </a:ln>
         </p:spPr>
+        <p:txBody>
+          <a:bodyPr/>
+          <a:p/>
+        </p:txBody>
       </p:sp>
       <p:sp>
         <p:nvSpPr>
@@ -13930,6 +14010,10 @@
             </a:outerShdw>
           </a:effectLst>
         </p:spPr>
+        <p:txBody>
+          <a:bodyPr/>
+          <a:p/>
+        </p:txBody>
       </p:sp>
       <p:sp>
         <p:nvSpPr>
@@ -13957,6 +14041,10 @@
             <a:prstDash val="solid"/>
           </a:ln>
         </p:spPr>
+        <p:txBody>
+          <a:bodyPr/>
+          <a:p/>
+        </p:txBody>
       </p:sp>
       <p:pic>
         <p:nvPicPr>
@@ -14089,6 +14177,10 @@
             <a:prstDash val="solid"/>
           </a:ln>
         </p:spPr>
+        <p:txBody>
+          <a:bodyPr/>
+          <a:p/>
+        </p:txBody>
       </p:sp>
       <p:sp>
         <p:nvSpPr>
@@ -14155,6 +14247,10 @@
             <a:prstDash val="solid"/>
           </a:ln>
         </p:spPr>
+        <p:txBody>
+          <a:bodyPr/>
+          <a:p/>
+        </p:txBody>
       </p:sp>
       <p:sp>
         <p:nvSpPr>
@@ -14221,6 +14317,10 @@
             <a:prstDash val="solid"/>
           </a:ln>
         </p:spPr>
+        <p:txBody>
+          <a:bodyPr/>
+          <a:p/>
+        </p:txBody>
       </p:sp>
       <p:sp>
         <p:nvSpPr>
@@ -14287,6 +14387,10 @@
             <a:prstDash val="solid"/>
           </a:ln>
         </p:spPr>
+        <p:txBody>
+          <a:bodyPr/>
+          <a:p/>
+        </p:txBody>
       </p:sp>
       <p:sp>
         <p:nvSpPr>
@@ -14360,6 +14464,10 @@
             </a:outerShdw>
           </a:effectLst>
         </p:spPr>
+        <p:txBody>
+          <a:bodyPr/>
+          <a:p/>
+        </p:txBody>
       </p:sp>
       <p:sp>
         <p:nvSpPr>
@@ -14387,6 +14495,10 @@
             <a:prstDash val="solid"/>
           </a:ln>
         </p:spPr>
+        <p:txBody>
+          <a:bodyPr/>
+          <a:p/>
+        </p:txBody>
       </p:sp>
       <p:pic>
         <p:nvPicPr>
@@ -14526,6 +14638,10 @@
             </a:outerShdw>
           </a:effectLst>
         </p:spPr>
+        <p:txBody>
+          <a:bodyPr/>
+          <a:p/>
+        </p:txBody>
       </p:sp>
       <p:sp>
         <p:nvSpPr>
@@ -14553,6 +14669,10 @@
             <a:prstDash val="solid"/>
           </a:ln>
         </p:spPr>
+        <p:txBody>
+          <a:bodyPr/>
+          <a:p/>
+        </p:txBody>
       </p:sp>
       <p:pic>
         <p:nvPicPr>
@@ -14685,6 +14805,10 @@
             <a:prstDash val="solid"/>
           </a:ln>
         </p:spPr>
+        <p:txBody>
+          <a:bodyPr/>
+          <a:p/>
+        </p:txBody>
       </p:sp>
       <p:sp>
         <p:nvSpPr>
@@ -14751,6 +14875,10 @@
             <a:prstDash val="solid"/>
           </a:ln>
         </p:spPr>
+        <p:txBody>
+          <a:bodyPr/>
+          <a:p/>
+        </p:txBody>
       </p:sp>
       <p:sp>
         <p:nvSpPr>
@@ -14817,6 +14945,10 @@
             <a:prstDash val="solid"/>
           </a:ln>
         </p:spPr>
+        <p:txBody>
+          <a:bodyPr/>
+          <a:p/>
+        </p:txBody>
       </p:sp>
       <p:sp>
         <p:nvSpPr>
@@ -14883,6 +15015,10 @@
             <a:prstDash val="solid"/>
           </a:ln>
         </p:spPr>
+        <p:txBody>
+          <a:bodyPr/>
+          <a:p/>
+        </p:txBody>
       </p:sp>
       <p:sp>
         <p:nvSpPr>
@@ -14949,6 +15085,10 @@
             <a:prstDash val="solid"/>
           </a:ln>
         </p:spPr>
+        <p:txBody>
+          <a:bodyPr/>
+          <a:p/>
+        </p:txBody>
       </p:sp>
       <p:sp>
         <p:nvSpPr>
@@ -15022,6 +15162,10 @@
             </a:outerShdw>
           </a:effectLst>
         </p:spPr>
+        <p:txBody>
+          <a:bodyPr/>
+          <a:p/>
+        </p:txBody>
       </p:sp>
       <p:sp>
         <p:nvSpPr>
@@ -15411,6 +15555,10 @@
             </a:outerShdw>
           </a:effectLst>
         </p:spPr>
+        <p:txBody>
+          <a:bodyPr/>
+          <a:p/>
+        </p:txBody>
       </p:sp>
       <p:sp>
         <p:nvSpPr>
@@ -15438,6 +15586,10 @@
             <a:prstDash val="solid"/>
           </a:ln>
         </p:spPr>
+        <p:txBody>
+          <a:bodyPr/>
+          <a:p/>
+        </p:txBody>
       </p:sp>
       <p:pic>
         <p:nvPicPr>
@@ -15577,6 +15729,10 @@
             </a:outerShdw>
           </a:effectLst>
         </p:spPr>
+        <p:txBody>
+          <a:bodyPr/>
+          <a:p/>
+        </p:txBody>
       </p:sp>
       <p:sp>
         <p:nvSpPr>
@@ -15604,6 +15760,10 @@
             <a:prstDash val="solid"/>
           </a:ln>
         </p:spPr>
+        <p:txBody>
+          <a:bodyPr/>
+          <a:p/>
+        </p:txBody>
       </p:sp>
       <p:pic>
         <p:nvPicPr>
@@ -15743,6 +15903,10 @@
             </a:outerShdw>
           </a:effectLst>
         </p:spPr>
+        <p:txBody>
+          <a:bodyPr/>
+          <a:p/>
+        </p:txBody>
       </p:sp>
       <p:sp>
         <p:nvSpPr>
@@ -15770,6 +15934,10 @@
             <a:prstDash val="solid"/>
           </a:ln>
         </p:spPr>
+        <p:txBody>
+          <a:bodyPr/>
+          <a:p/>
+        </p:txBody>
       </p:sp>
       <p:pic>
         <p:nvPicPr>
@@ -16125,6 +16293,10 @@
             </a:outerShdw>
           </a:effectLst>
         </p:spPr>
+        <p:txBody>
+          <a:bodyPr/>
+          <a:p/>
+        </p:txBody>
       </p:sp>
       <p:sp>
         <p:nvSpPr>
@@ -16191,6 +16363,10 @@
             <a:prstDash val="solid"/>
           </a:ln>
         </p:spPr>
+        <p:txBody>
+          <a:bodyPr/>
+          <a:p/>
+        </p:txBody>
       </p:sp>
       <p:pic>
         <p:nvPicPr>
@@ -16354,6 +16530,10 @@
             </a:outerShdw>
           </a:effectLst>
         </p:spPr>
+        <p:txBody>
+          <a:bodyPr/>
+          <a:p/>
+        </p:txBody>
       </p:sp>
       <p:sp>
         <p:nvSpPr>
@@ -16420,6 +16600,10 @@
             <a:prstDash val="solid"/>
           </a:ln>
         </p:spPr>
+        <p:txBody>
+          <a:bodyPr/>
+          <a:p/>
+        </p:txBody>
       </p:sp>
       <p:pic>
         <p:nvPicPr>
@@ -16583,6 +16767,10 @@
             </a:outerShdw>
           </a:effectLst>
         </p:spPr>
+        <p:txBody>
+          <a:bodyPr/>
+          <a:p/>
+        </p:txBody>
       </p:sp>
       <p:sp>
         <p:nvSpPr>
@@ -16649,6 +16837,10 @@
             <a:prstDash val="solid"/>
           </a:ln>
         </p:spPr>
+        <p:txBody>
+          <a:bodyPr/>
+          <a:p/>
+        </p:txBody>
       </p:sp>
       <p:pic>
         <p:nvPicPr>
@@ -16812,6 +17004,10 @@
             </a:outerShdw>
           </a:effectLst>
         </p:spPr>
+        <p:txBody>
+          <a:bodyPr/>
+          <a:p/>
+        </p:txBody>
       </p:sp>
       <p:sp>
         <p:nvSpPr>
@@ -16878,6 +17074,10 @@
             <a:prstDash val="solid"/>
           </a:ln>
         </p:spPr>
+        <p:txBody>
+          <a:bodyPr/>
+          <a:p/>
+        </p:txBody>
       </p:sp>
       <p:pic>
         <p:nvPicPr>
@@ -17233,6 +17433,10 @@
             </a:outerShdw>
           </a:effectLst>
         </p:spPr>
+        <p:txBody>
+          <a:bodyPr/>
+          <a:p/>
+        </p:txBody>
       </p:sp>
       <p:sp>
         <p:nvSpPr>
@@ -17260,6 +17464,10 @@
             <a:prstDash val="solid"/>
           </a:ln>
         </p:spPr>
+        <p:txBody>
+          <a:bodyPr/>
+          <a:p/>
+        </p:txBody>
       </p:sp>
       <p:pic>
         <p:nvPicPr>
@@ -17419,6 +17627,10 @@
             </a:outerShdw>
           </a:effectLst>
         </p:spPr>
+        <p:txBody>
+          <a:bodyPr/>
+          <a:p/>
+        </p:txBody>
       </p:sp>
       <p:sp>
         <p:nvSpPr>
@@ -17446,6 +17658,10 @@
             <a:prstDash val="solid"/>
           </a:ln>
         </p:spPr>
+        <p:txBody>
+          <a:bodyPr/>
+          <a:p/>
+        </p:txBody>
       </p:sp>
       <p:pic>
         <p:nvPicPr>
@@ -17605,6 +17821,10 @@
             </a:outerShdw>
           </a:effectLst>
         </p:spPr>
+        <p:txBody>
+          <a:bodyPr/>
+          <a:p/>
+        </p:txBody>
       </p:sp>
       <p:sp>
         <p:nvSpPr>
@@ -17632,6 +17852,10 @@
             <a:prstDash val="solid"/>
           </a:ln>
         </p:spPr>
+        <p:txBody>
+          <a:bodyPr/>
+          <a:p/>
+        </p:txBody>
       </p:sp>
       <p:pic>
         <p:nvPicPr>
@@ -17791,6 +18015,10 @@
             </a:outerShdw>
           </a:effectLst>
         </p:spPr>
+        <p:txBody>
+          <a:bodyPr/>
+          <a:p/>
+        </p:txBody>
       </p:sp>
       <p:sp>
         <p:nvSpPr>
@@ -17818,6 +18046,10 @@
             <a:prstDash val="solid"/>
           </a:ln>
         </p:spPr>
+        <p:txBody>
+          <a:bodyPr/>
+          <a:p/>
+        </p:txBody>
       </p:sp>
       <p:pic>
         <p:nvPicPr>
@@ -17977,6 +18209,10 @@
             </a:outerShdw>
           </a:effectLst>
         </p:spPr>
+        <p:txBody>
+          <a:bodyPr/>
+          <a:p/>
+        </p:txBody>
       </p:sp>
       <p:sp>
         <p:nvSpPr>
@@ -18488,6 +18724,10 @@
             <a:prstDash val="solid"/>
           </a:ln>
         </p:spPr>
+        <p:txBody>
+          <a:bodyPr/>
+          <a:p/>
+        </p:txBody>
       </p:sp>
       <p:sp>
         <p:nvSpPr>
@@ -18515,6 +18755,10 @@
             <a:prstDash val="solid"/>
           </a:ln>
         </p:spPr>
+        <p:txBody>
+          <a:bodyPr/>
+          <a:p/>
+        </p:txBody>
       </p:sp>
       <p:sp>
         <p:nvSpPr>
@@ -18542,6 +18786,10 @@
             <a:prstDash val="solid"/>
           </a:ln>
         </p:spPr>
+        <p:txBody>
+          <a:bodyPr/>
+          <a:p/>
+        </p:txBody>
       </p:sp>
       <p:pic>
         <p:nvPicPr>
@@ -18674,6 +18922,10 @@
             <a:prstDash val="solid"/>
           </a:ln>
         </p:spPr>
+        <p:txBody>
+          <a:bodyPr/>
+          <a:p/>
+        </p:txBody>
       </p:sp>
       <p:sp>
         <p:nvSpPr>
@@ -18701,6 +18953,10 @@
             <a:prstDash val="solid"/>
           </a:ln>
         </p:spPr>
+        <p:txBody>
+          <a:bodyPr/>
+          <a:p/>
+        </p:txBody>
       </p:sp>
       <p:pic>
         <p:nvPicPr>
@@ -18833,6 +19089,10 @@
             <a:prstDash val="solid"/>
           </a:ln>
         </p:spPr>
+        <p:txBody>
+          <a:bodyPr/>
+          <a:p/>
+        </p:txBody>
       </p:sp>
       <p:sp>
         <p:nvSpPr>
@@ -18860,6 +19120,10 @@
             <a:prstDash val="solid"/>
           </a:ln>
         </p:spPr>
+        <p:txBody>
+          <a:bodyPr/>
+          <a:p/>
+        </p:txBody>
       </p:sp>
       <p:pic>
         <p:nvPicPr>
@@ -18992,6 +19256,10 @@
             <a:prstDash val="solid"/>
           </a:ln>
         </p:spPr>
+        <p:txBody>
+          <a:bodyPr/>
+          <a:p/>
+        </p:txBody>
       </p:sp>
       <p:sp>
         <p:nvSpPr>
@@ -19019,6 +19287,10 @@
             <a:prstDash val="solid"/>
           </a:ln>
         </p:spPr>
+        <p:txBody>
+          <a:bodyPr/>
+          <a:p/>
+        </p:txBody>
       </p:sp>
       <p:pic>
         <p:nvPicPr>
@@ -19151,6 +19423,10 @@
             <a:prstDash val="solid"/>
           </a:ln>
         </p:spPr>
+        <p:txBody>
+          <a:bodyPr/>
+          <a:p/>
+        </p:txBody>
       </p:sp>
       <p:sp>
         <p:nvSpPr>
@@ -19178,6 +19454,10 @@
             <a:prstDash val="solid"/>
           </a:ln>
         </p:spPr>
+        <p:txBody>
+          <a:bodyPr/>
+          <a:p/>
+        </p:txBody>
       </p:sp>
       <p:pic>
         <p:nvPicPr>
@@ -19533,6 +19813,10 @@
             </a:outerShdw>
           </a:effectLst>
         </p:spPr>
+        <p:txBody>
+          <a:bodyPr/>
+          <a:p/>
+        </p:txBody>
       </p:sp>
       <p:sp>
         <p:nvSpPr>
@@ -19560,6 +19844,10 @@
             <a:prstDash val="solid"/>
           </a:ln>
         </p:spPr>
+        <p:txBody>
+          <a:bodyPr/>
+          <a:p/>
+        </p:txBody>
       </p:sp>
       <p:pic>
         <p:nvPicPr>
@@ -19699,6 +19987,10 @@
             </a:outerShdw>
           </a:effectLst>
         </p:spPr>
+        <p:txBody>
+          <a:bodyPr/>
+          <a:p/>
+        </p:txBody>
       </p:sp>
       <p:sp>
         <p:nvSpPr>
@@ -19726,6 +20018,10 @@
             <a:prstDash val="solid"/>
           </a:ln>
         </p:spPr>
+        <p:txBody>
+          <a:bodyPr/>
+          <a:p/>
+        </p:txBody>
       </p:sp>
       <p:pic>
         <p:nvPicPr>
@@ -19865,6 +20161,10 @@
             </a:outerShdw>
           </a:effectLst>
         </p:spPr>
+        <p:txBody>
+          <a:bodyPr/>
+          <a:p/>
+        </p:txBody>
       </p:sp>
       <p:sp>
         <p:nvSpPr>
@@ -19892,6 +20192,10 @@
             <a:prstDash val="solid"/>
           </a:ln>
         </p:spPr>
+        <p:txBody>
+          <a:bodyPr/>
+          <a:p/>
+        </p:txBody>
       </p:sp>
       <p:pic>
         <p:nvPicPr>
@@ -20031,6 +20335,10 @@
             </a:outerShdw>
           </a:effectLst>
         </p:spPr>
+        <p:txBody>
+          <a:bodyPr/>
+          <a:p/>
+        </p:txBody>
       </p:sp>
       <p:sp>
         <p:nvSpPr>
@@ -20058,6 +20366,10 @@
             <a:prstDash val="solid"/>
           </a:ln>
         </p:spPr>
+        <p:txBody>
+          <a:bodyPr/>
+          <a:p/>
+        </p:txBody>
       </p:sp>
       <p:pic>
         <p:nvPicPr>
@@ -20197,6 +20509,10 @@
             </a:outerShdw>
           </a:effectLst>
         </p:spPr>
+        <p:txBody>
+          <a:bodyPr/>
+          <a:p/>
+        </p:txBody>
       </p:sp>
       <p:sp>
         <p:nvSpPr>
@@ -20224,6 +20540,10 @@
             <a:prstDash val="solid"/>
           </a:ln>
         </p:spPr>
+        <p:txBody>
+          <a:bodyPr/>
+          <a:p/>
+        </p:txBody>
       </p:sp>
       <p:pic>
         <p:nvPicPr>
@@ -20363,6 +20683,10 @@
             </a:outerShdw>
           </a:effectLst>
         </p:spPr>
+        <p:txBody>
+          <a:bodyPr/>
+          <a:p/>
+        </p:txBody>
       </p:sp>
       <p:sp>
         <p:nvSpPr>
@@ -20390,6 +20714,10 @@
             <a:prstDash val="solid"/>
           </a:ln>
         </p:spPr>
+        <p:txBody>
+          <a:bodyPr/>
+          <a:p/>
+        </p:txBody>
       </p:sp>
       <p:pic>
         <p:nvPicPr>
@@ -20784,6 +21112,10 @@
             </a:outerShdw>
           </a:effectLst>
         </p:spPr>
+        <p:txBody>
+          <a:bodyPr/>
+          <a:p/>
+        </p:txBody>
       </p:sp>
       <p:sp>
         <p:nvSpPr>
@@ -20809,6 +21141,10 @@
             <a:prstDash val="solid"/>
           </a:ln>
         </p:spPr>
+        <p:txBody>
+          <a:bodyPr/>
+          <a:p/>
+        </p:txBody>
       </p:sp>
       <p:pic>
         <p:nvPicPr>
@@ -20867,7 +21203,7 @@
                 <a:ea typeface="Calibri" pitchFamily="34" charset="-122"/>
                 <a:cs typeface="Calibri" pitchFamily="34" charset="-120"/>
               </a:rPr>
-              <a:t>GMO Cybersecurity by Ierae, Inc.</a:t>
+              <a:t>GMO Cybersecurity by Ierae</a:t>
             </a:r>
             <a:endParaRPr lang="en-US" sz="1800" dirty="0"/>
           </a:p>
@@ -20938,6 +21274,10 @@
             <a:prstDash val="solid"/>
           </a:ln>
         </p:spPr>
+        <p:txBody>
+          <a:bodyPr/>
+          <a:p/>
+        </p:txBody>
       </p:sp>
       <p:pic>
         <p:nvPicPr>
@@ -21028,6 +21368,10 @@
             <a:prstDash val="solid"/>
           </a:ln>
         </p:spPr>
+        <p:txBody>
+          <a:bodyPr/>
+          <a:p/>
+        </p:txBody>
       </p:sp>
       <p:pic>
         <p:nvPicPr>
@@ -21323,6 +21667,10 @@
             <a:prstDash val="solid"/>
           </a:ln>
         </p:spPr>
+        <p:txBody>
+          <a:bodyPr/>
+          <a:p/>
+        </p:txBody>
       </p:sp>
       <p:sp>
         <p:nvSpPr>
@@ -21389,6 +21737,10 @@
             <a:prstDash val="solid"/>
           </a:ln>
         </p:spPr>
+        <p:txBody>
+          <a:bodyPr/>
+          <a:p/>
+        </p:txBody>
       </p:sp>
       <p:sp>
         <p:nvSpPr>
@@ -21455,6 +21807,10 @@
             <a:prstDash val="solid"/>
           </a:ln>
         </p:spPr>
+        <p:txBody>
+          <a:bodyPr/>
+          <a:p/>
+        </p:txBody>
       </p:sp>
       <p:sp>
         <p:nvSpPr>
@@ -21521,6 +21877,10 @@
             <a:prstDash val="solid"/>
           </a:ln>
         </p:spPr>
+        <p:txBody>
+          <a:bodyPr/>
+          <a:p/>
+        </p:txBody>
       </p:sp>
       <p:sp>
         <p:nvSpPr>
@@ -21587,6 +21947,10 @@
             <a:prstDash val="solid"/>
           </a:ln>
         </p:spPr>
+        <p:txBody>
+          <a:bodyPr/>
+          <a:p/>
+        </p:txBody>
       </p:sp>
       <p:sp>
         <p:nvSpPr>
@@ -21653,6 +22017,10 @@
             <a:prstDash val="solid"/>
           </a:ln>
         </p:spPr>
+        <p:txBody>
+          <a:bodyPr/>
+          <a:p/>
+        </p:txBody>
       </p:sp>
       <p:sp>
         <p:nvSpPr>
@@ -21719,6 +22087,10 @@
             <a:prstDash val="solid"/>
           </a:ln>
         </p:spPr>
+        <p:txBody>
+          <a:bodyPr/>
+          <a:p/>
+        </p:txBody>
       </p:sp>
       <p:sp>
         <p:nvSpPr>
@@ -22008,6 +22380,10 @@
             </a:outerShdw>
           </a:effectLst>
         </p:spPr>
+        <p:txBody>
+          <a:bodyPr/>
+          <a:p/>
+        </p:txBody>
       </p:sp>
       <p:sp>
         <p:nvSpPr>
@@ -22035,6 +22411,10 @@
             <a:prstDash val="solid"/>
           </a:ln>
         </p:spPr>
+        <p:txBody>
+          <a:bodyPr/>
+          <a:p/>
+        </p:txBody>
       </p:sp>
       <p:pic>
         <p:nvPicPr>
@@ -22174,6 +22554,10 @@
             </a:outerShdw>
           </a:effectLst>
         </p:spPr>
+        <p:txBody>
+          <a:bodyPr/>
+          <a:p/>
+        </p:txBody>
       </p:sp>
       <p:sp>
         <p:nvSpPr>
@@ -22201,6 +22585,10 @@
             <a:prstDash val="solid"/>
           </a:ln>
         </p:spPr>
+        <p:txBody>
+          <a:bodyPr/>
+          <a:p/>
+        </p:txBody>
       </p:sp>
       <p:pic>
         <p:nvPicPr>
@@ -22340,6 +22728,10 @@
             </a:outerShdw>
           </a:effectLst>
         </p:spPr>
+        <p:txBody>
+          <a:bodyPr/>
+          <a:p/>
+        </p:txBody>
       </p:sp>
       <p:sp>
         <p:nvSpPr>
@@ -22367,6 +22759,10 @@
             <a:prstDash val="solid"/>
           </a:ln>
         </p:spPr>
+        <p:txBody>
+          <a:bodyPr/>
+          <a:p/>
+        </p:txBody>
       </p:sp>
       <p:pic>
         <p:nvPicPr>
@@ -22506,6 +22902,10 @@
             </a:outerShdw>
           </a:effectLst>
         </p:spPr>
+        <p:txBody>
+          <a:bodyPr/>
+          <a:p/>
+        </p:txBody>
       </p:sp>
       <p:sp>
         <p:nvSpPr>
@@ -22533,6 +22933,10 @@
             <a:prstDash val="solid"/>
           </a:ln>
         </p:spPr>
+        <p:txBody>
+          <a:bodyPr/>
+          <a:p/>
+        </p:txBody>
       </p:sp>
       <p:pic>
         <p:nvPicPr>
@@ -22672,6 +23076,10 @@
             </a:outerShdw>
           </a:effectLst>
         </p:spPr>
+        <p:txBody>
+          <a:bodyPr/>
+          <a:p/>
+        </p:txBody>
       </p:sp>
       <p:sp>
         <p:nvSpPr>
@@ -22699,6 +23107,10 @@
             <a:prstDash val="solid"/>
           </a:ln>
         </p:spPr>
+        <p:txBody>
+          <a:bodyPr/>
+          <a:p/>
+        </p:txBody>
       </p:sp>
       <p:pic>
         <p:nvPicPr>
@@ -22838,6 +23250,10 @@
             </a:outerShdw>
           </a:effectLst>
         </p:spPr>
+        <p:txBody>
+          <a:bodyPr/>
+          <a:p/>
+        </p:txBody>
       </p:sp>
       <p:sp>
         <p:nvSpPr>
@@ -22865,6 +23281,10 @@
             <a:prstDash val="solid"/>
           </a:ln>
         </p:spPr>
+        <p:txBody>
+          <a:bodyPr/>
+          <a:p/>
+        </p:txBody>
       </p:sp>
       <p:pic>
         <p:nvPicPr>
@@ -23004,6 +23424,10 @@
             </a:outerShdw>
           </a:effectLst>
         </p:spPr>
+        <p:txBody>
+          <a:bodyPr/>
+          <a:p/>
+        </p:txBody>
       </p:sp>
       <p:sp>
         <p:nvSpPr>
@@ -23031,6 +23455,10 @@
             <a:prstDash val="solid"/>
           </a:ln>
         </p:spPr>
+        <p:txBody>
+          <a:bodyPr/>
+          <a:p/>
+        </p:txBody>
       </p:sp>
       <p:pic>
         <p:nvPicPr>
@@ -23170,6 +23598,10 @@
             </a:outerShdw>
           </a:effectLst>
         </p:spPr>
+        <p:txBody>
+          <a:bodyPr/>
+          <a:p/>
+        </p:txBody>
       </p:sp>
       <p:sp>
         <p:nvSpPr>
@@ -23197,6 +23629,10 @@
             <a:prstDash val="solid"/>
           </a:ln>
         </p:spPr>
+        <p:txBody>
+          <a:bodyPr/>
+          <a:p/>
+        </p:txBody>
       </p:sp>
       <p:pic>
         <p:nvPicPr>
@@ -23552,6 +23988,10 @@
             </a:outerShdw>
           </a:effectLst>
         </p:spPr>
+        <p:txBody>
+          <a:bodyPr/>
+          <a:p/>
+        </p:txBody>
       </p:sp>
       <p:pic>
         <p:nvPicPr>
@@ -23752,6 +24192,10 @@
             </a:outerShdw>
           </a:effectLst>
         </p:spPr>
+        <p:txBody>
+          <a:bodyPr/>
+          <a:p/>
+        </p:txBody>
       </p:sp>
       <p:pic>
         <p:nvPicPr>
@@ -24231,6 +24675,10 @@
             </a:outerShdw>
           </a:effectLst>
         </p:spPr>
+        <p:txBody>
+          <a:bodyPr/>
+          <a:p/>
+        </p:txBody>
       </p:sp>
       <p:sp>
         <p:nvSpPr>
@@ -24336,6 +24784,10 @@
             <a:prstDash val="solid"/>
           </a:ln>
         </p:spPr>
+        <p:txBody>
+          <a:bodyPr/>
+          <a:p/>
+        </p:txBody>
       </p:sp>
       <p:sp>
         <p:nvSpPr>
@@ -24441,6 +24893,10 @@
             <a:prstDash val="solid"/>
           </a:ln>
         </p:spPr>
+        <p:txBody>
+          <a:bodyPr/>
+          <a:p/>
+        </p:txBody>
       </p:sp>
       <p:sp>
         <p:nvSpPr>
@@ -24546,6 +25002,10 @@
             <a:prstDash val="solid"/>
           </a:ln>
         </p:spPr>
+        <p:txBody>
+          <a:bodyPr/>
+          <a:p/>
+        </p:txBody>
       </p:sp>
       <p:sp>
         <p:nvSpPr>
@@ -24651,6 +25111,10 @@
             <a:prstDash val="solid"/>
           </a:ln>
         </p:spPr>
+        <p:txBody>
+          <a:bodyPr/>
+          <a:p/>
+        </p:txBody>
       </p:sp>
       <p:sp>
         <p:nvSpPr>
@@ -24724,6 +25188,10 @@
             </a:outerShdw>
           </a:effectLst>
         </p:spPr>
+        <p:txBody>
+          <a:bodyPr/>
+          <a:p/>
+        </p:txBody>
       </p:sp>
       <p:pic>
         <p:nvPicPr>
@@ -25450,6 +25918,10 @@
             <a:prstDash val="solid"/>
           </a:ln>
         </p:spPr>
+        <p:txBody>
+          <a:bodyPr/>
+          <a:p/>
+        </p:txBody>
       </p:sp>
       <p:sp>
         <p:nvSpPr>
@@ -25753,6 +26225,10 @@
             <a:prstDash val="solid"/>
           </a:ln>
         </p:spPr>
+        <p:txBody>
+          <a:bodyPr/>
+          <a:p/>
+        </p:txBody>
       </p:sp>
       <p:sp>
         <p:nvSpPr>
@@ -26226,6 +26702,10 @@
             </a:outerShdw>
           </a:effectLst>
         </p:spPr>
+        <p:txBody>
+          <a:bodyPr/>
+          <a:p/>
+        </p:txBody>
       </p:sp>
       <p:sp>
         <p:nvSpPr>
@@ -26432,6 +26912,10 @@
             </a:outerShdw>
           </a:effectLst>
         </p:spPr>
+        <p:txBody>
+          <a:bodyPr/>
+          <a:p/>
+        </p:txBody>
       </p:sp>
       <p:pic>
         <p:nvPicPr>
@@ -26762,6 +27246,10 @@
             </a:outerShdw>
           </a:effectLst>
         </p:spPr>
+        <p:txBody>
+          <a:bodyPr/>
+          <a:p/>
+        </p:txBody>
       </p:sp>
       <p:pic>
         <p:nvPicPr>
@@ -26926,6 +27414,10 @@
             <a:prstDash val="solid"/>
           </a:ln>
         </p:spPr>
+        <p:txBody>
+          <a:bodyPr/>
+          <a:p/>
+        </p:txBody>
       </p:sp>
       <p:sp>
         <p:nvSpPr>
@@ -26953,6 +27445,10 @@
             <a:prstDash val="solid"/>
           </a:ln>
         </p:spPr>
+        <p:txBody>
+          <a:bodyPr/>
+          <a:p/>
+        </p:txBody>
       </p:sp>
       <p:pic>
         <p:nvPicPr>
@@ -27082,6 +27578,10 @@
             <a:prstDash val="solid"/>
           </a:ln>
         </p:spPr>
+        <p:txBody>
+          <a:bodyPr/>
+          <a:p/>
+        </p:txBody>
       </p:sp>
       <p:pic>
         <p:nvPicPr>
@@ -27211,6 +27711,10 @@
             <a:prstDash val="solid"/>
           </a:ln>
         </p:spPr>
+        <p:txBody>
+          <a:bodyPr/>
+          <a:p/>
+        </p:txBody>
       </p:sp>
       <p:pic>
         <p:nvPicPr>
@@ -27347,7 +27851,7 @@
                 <a:ea typeface="Courier New" pitchFamily="34" charset="-122"/>
                 <a:cs typeface="Courier New" pitchFamily="34" charset="-120"/>
               </a:rPr>
-              <a:t>Makoto Sugita · Mr.Rabbit · GMO Cybersecurity by Ierae, Inc. · Apache-2.0</a:t>
+              <a:t>Makoto Sugita · Mr.Rabbit · GMO Cybersecurity by Ierae · Apache-2.0</a:t>
             </a:r>
             <a:endParaRPr lang="en-US" sz="1200" dirty="0"/>
           </a:p>
@@ -27489,6 +27993,10 @@
             <a:prstDash val="solid"/>
           </a:ln>
         </p:spPr>
+        <p:txBody>
+          <a:bodyPr/>
+          <a:p/>
+        </p:txBody>
       </p:sp>
       <p:sp>
         <p:nvSpPr>
@@ -27555,6 +28063,10 @@
             <a:prstDash val="solid"/>
           </a:ln>
         </p:spPr>
+        <p:txBody>
+          <a:bodyPr/>
+          <a:p/>
+        </p:txBody>
       </p:sp>
       <p:pic>
         <p:nvPicPr>
@@ -27684,6 +28196,10 @@
             <a:prstDash val="solid"/>
           </a:ln>
         </p:spPr>
+        <p:txBody>
+          <a:bodyPr/>
+          <a:p/>
+        </p:txBody>
       </p:sp>
       <p:sp>
         <p:nvSpPr>
@@ -27750,6 +28266,10 @@
             <a:prstDash val="solid"/>
           </a:ln>
         </p:spPr>
+        <p:txBody>
+          <a:bodyPr/>
+          <a:p/>
+        </p:txBody>
       </p:sp>
       <p:pic>
         <p:nvPicPr>
@@ -27879,6 +28399,10 @@
             <a:prstDash val="solid"/>
           </a:ln>
         </p:spPr>
+        <p:txBody>
+          <a:bodyPr/>
+          <a:p/>
+        </p:txBody>
       </p:sp>
       <p:sp>
         <p:nvSpPr>
@@ -27945,6 +28469,10 @@
             <a:prstDash val="solid"/>
           </a:ln>
         </p:spPr>
+        <p:txBody>
+          <a:bodyPr/>
+          <a:p/>
+        </p:txBody>
       </p:sp>
       <p:pic>
         <p:nvPicPr>
@@ -28074,6 +28602,10 @@
             <a:prstDash val="solid"/>
           </a:ln>
         </p:spPr>
+        <p:txBody>
+          <a:bodyPr/>
+          <a:p/>
+        </p:txBody>
       </p:sp>
       <p:sp>
         <p:nvSpPr>
@@ -28140,6 +28672,10 @@
             <a:prstDash val="solid"/>
           </a:ln>
         </p:spPr>
+        <p:txBody>
+          <a:bodyPr/>
+          <a:p/>
+        </p:txBody>
       </p:sp>
       <p:pic>
         <p:nvPicPr>
@@ -28269,6 +28805,10 @@
             <a:prstDash val="solid"/>
           </a:ln>
         </p:spPr>
+        <p:txBody>
+          <a:bodyPr/>
+          <a:p/>
+        </p:txBody>
       </p:sp>
       <p:sp>
         <p:nvSpPr>
@@ -28335,6 +28875,10 @@
             <a:prstDash val="solid"/>
           </a:ln>
         </p:spPr>
+        <p:txBody>
+          <a:bodyPr/>
+          <a:p/>
+        </p:txBody>
       </p:sp>
       <p:pic>
         <p:nvPicPr>
@@ -28464,6 +29008,10 @@
             <a:prstDash val="solid"/>
           </a:ln>
         </p:spPr>
+        <p:txBody>
+          <a:bodyPr/>
+          <a:p/>
+        </p:txBody>
       </p:sp>
       <p:sp>
         <p:nvSpPr>
@@ -28530,6 +29078,10 @@
             <a:prstDash val="solid"/>
           </a:ln>
         </p:spPr>
+        <p:txBody>
+          <a:bodyPr/>
+          <a:p/>
+        </p:txBody>
       </p:sp>
       <p:pic>
         <p:nvPicPr>
@@ -28921,6 +29473,10 @@
             </a:outerShdw>
           </a:effectLst>
         </p:spPr>
+        <p:txBody>
+          <a:bodyPr/>
+          <a:p/>
+        </p:txBody>
       </p:sp>
       <p:sp>
         <p:nvSpPr>
@@ -28948,6 +29504,10 @@
             <a:prstDash val="solid"/>
           </a:ln>
         </p:spPr>
+        <p:txBody>
+          <a:bodyPr/>
+          <a:p/>
+        </p:txBody>
       </p:sp>
       <p:pic>
         <p:nvPicPr>
@@ -29087,6 +29647,10 @@
             </a:outerShdw>
           </a:effectLst>
         </p:spPr>
+        <p:txBody>
+          <a:bodyPr/>
+          <a:p/>
+        </p:txBody>
       </p:sp>
       <p:sp>
         <p:nvSpPr>
@@ -29114,6 +29678,10 @@
             <a:prstDash val="solid"/>
           </a:ln>
         </p:spPr>
+        <p:txBody>
+          <a:bodyPr/>
+          <a:p/>
+        </p:txBody>
       </p:sp>
       <p:pic>
         <p:nvPicPr>
@@ -29253,6 +29821,10 @@
             </a:outerShdw>
           </a:effectLst>
         </p:spPr>
+        <p:txBody>
+          <a:bodyPr/>
+          <a:p/>
+        </p:txBody>
       </p:sp>
       <p:sp>
         <p:nvSpPr>
@@ -29280,6 +29852,10 @@
             <a:prstDash val="solid"/>
           </a:ln>
         </p:spPr>
+        <p:txBody>
+          <a:bodyPr/>
+          <a:p/>
+        </p:txBody>
       </p:sp>
       <p:pic>
         <p:nvPicPr>
@@ -29681,6 +30257,10 @@
             </a:outerShdw>
           </a:effectLst>
         </p:spPr>
+        <p:txBody>
+          <a:bodyPr/>
+          <a:p/>
+        </p:txBody>
       </p:sp>
       <p:sp>
         <p:nvSpPr>
@@ -29868,6 +30448,10 @@
             </a:outerShdw>
           </a:effectLst>
         </p:spPr>
+        <p:txBody>
+          <a:bodyPr/>
+          <a:p/>
+        </p:txBody>
       </p:sp>
       <p:sp>
         <p:nvSpPr>
@@ -30055,6 +30639,10 @@
             </a:outerShdw>
           </a:effectLst>
         </p:spPr>
+        <p:txBody>
+          <a:bodyPr/>
+          <a:p/>
+        </p:txBody>
       </p:sp>
       <p:sp>
         <p:nvSpPr>
@@ -30497,6 +31085,10 @@
             </a:outerShdw>
           </a:effectLst>
         </p:spPr>
+        <p:txBody>
+          <a:bodyPr/>
+          <a:p/>
+        </p:txBody>
       </p:sp>
       <p:pic>
         <p:nvPicPr>
@@ -30700,6 +31292,10 @@
             </a:outerShdw>
           </a:effectLst>
         </p:spPr>
+        <p:txBody>
+          <a:bodyPr/>
+          <a:p/>
+        </p:txBody>
       </p:sp>
       <p:pic>
         <p:nvPicPr>
@@ -31158,6 +31754,10 @@
             </a:outerShdw>
           </a:effectLst>
         </p:spPr>
+        <p:txBody>
+          <a:bodyPr/>
+          <a:p/>
+        </p:txBody>
       </p:sp>
       <p:sp>
         <p:nvSpPr>
@@ -31185,6 +31785,10 @@
             <a:prstDash val="solid"/>
           </a:ln>
         </p:spPr>
+        <p:txBody>
+          <a:bodyPr/>
+          <a:p/>
+        </p:txBody>
       </p:sp>
       <p:pic>
         <p:nvPicPr>
@@ -31367,6 +31971,10 @@
             </a:outerShdw>
           </a:effectLst>
         </p:spPr>
+        <p:txBody>
+          <a:bodyPr/>
+          <a:p/>
+        </p:txBody>
       </p:sp>
       <p:sp>
         <p:nvSpPr>
@@ -31394,6 +32002,10 @@
             <a:prstDash val="solid"/>
           </a:ln>
         </p:spPr>
+        <p:txBody>
+          <a:bodyPr/>
+          <a:p/>
+        </p:txBody>
       </p:sp>
       <p:pic>
         <p:nvPicPr>
@@ -31567,6 +32179,10 @@
             <a:prstDash val="solid"/>
           </a:ln>
         </p:spPr>
+        <p:txBody>
+          <a:bodyPr/>
+          <a:p/>
+        </p:txBody>
       </p:sp>
       <p:pic>
         <p:nvPicPr>
@@ -31841,6 +32457,10 @@
             </a:outerShdw>
           </a:effectLst>
         </p:spPr>
+        <p:txBody>
+          <a:bodyPr/>
+          <a:p/>
+        </p:txBody>
       </p:sp>
       <p:pic>
         <p:nvPicPr>
@@ -31931,6 +32551,10 @@
             <a:prstDash val="solid"/>
           </a:ln>
         </p:spPr>
+        <p:txBody>
+          <a:bodyPr/>
+          <a:p/>
+        </p:txBody>
       </p:sp>
       <p:pic>
         <p:nvPicPr>
@@ -32060,6 +32684,10 @@
             <a:prstDash val="solid"/>
           </a:ln>
         </p:spPr>
+        <p:txBody>
+          <a:bodyPr/>
+          <a:p/>
+        </p:txBody>
       </p:sp>
       <p:pic>
         <p:nvPicPr>
@@ -32189,6 +32817,10 @@
             <a:prstDash val="solid"/>
           </a:ln>
         </p:spPr>
+        <p:txBody>
+          <a:bodyPr/>
+          <a:p/>
+        </p:txBody>
       </p:sp>
       <p:pic>
         <p:nvPicPr>
@@ -32318,6 +32950,10 @@
             <a:prstDash val="solid"/>
           </a:ln>
         </p:spPr>
+        <p:txBody>
+          <a:bodyPr/>
+          <a:p/>
+        </p:txBody>
       </p:sp>
       <p:pic>
         <p:nvPicPr>
@@ -32447,6 +33083,10 @@
             <a:prstDash val="solid"/>
           </a:ln>
         </p:spPr>
+        <p:txBody>
+          <a:bodyPr/>
+          <a:p/>
+        </p:txBody>
       </p:sp>
       <p:pic>
         <p:nvPicPr>
@@ -32583,6 +33223,10 @@
             </a:outerShdw>
           </a:effectLst>
         </p:spPr>
+        <p:txBody>
+          <a:bodyPr/>
+          <a:p/>
+        </p:txBody>
       </p:sp>
       <p:pic>
         <p:nvPicPr>
@@ -33332,6 +33976,10 @@
             </a:outerShdw>
           </a:effectLst>
         </p:spPr>
+        <p:txBody>
+          <a:bodyPr/>
+          <a:p/>
+        </p:txBody>
       </p:sp>
       <p:sp>
         <p:nvSpPr>
@@ -33472,6 +34120,10 @@
             <a:prstDash val="solid"/>
           </a:ln>
         </p:spPr>
+        <p:txBody>
+          <a:bodyPr/>
+          <a:p/>
+        </p:txBody>
       </p:sp>
       <p:sp>
         <p:nvSpPr>
@@ -33612,6 +34264,10 @@
             <a:prstDash val="solid"/>
           </a:ln>
         </p:spPr>
+        <p:txBody>
+          <a:bodyPr/>
+          <a:p/>
+        </p:txBody>
       </p:sp>
       <p:sp>
         <p:nvSpPr>
@@ -33752,6 +34408,10 @@
             <a:prstDash val="solid"/>
           </a:ln>
         </p:spPr>
+        <p:txBody>
+          <a:bodyPr/>
+          <a:p/>
+        </p:txBody>
       </p:sp>
       <p:sp>
         <p:nvSpPr>
@@ -33892,6 +34552,10 @@
             <a:prstDash val="solid"/>
           </a:ln>
         </p:spPr>
+        <p:txBody>
+          <a:bodyPr/>
+          <a:p/>
+        </p:txBody>
       </p:sp>
       <p:sp>
         <p:nvSpPr>
@@ -34032,6 +34696,10 @@
             <a:prstDash val="solid"/>
           </a:ln>
         </p:spPr>
+        <p:txBody>
+          <a:bodyPr/>
+          <a:p/>
+        </p:txBody>
       </p:sp>
       <p:sp>
         <p:nvSpPr>
@@ -34172,6 +34840,10 @@
             <a:prstDash val="solid"/>
           </a:ln>
         </p:spPr>
+        <p:txBody>
+          <a:bodyPr/>
+          <a:p/>
+        </p:txBody>
       </p:sp>
       <p:sp>
         <p:nvSpPr>
@@ -34312,6 +34984,10 @@
             <a:prstDash val="solid"/>
           </a:ln>
         </p:spPr>
+        <p:txBody>
+          <a:bodyPr/>
+          <a:p/>
+        </p:txBody>
       </p:sp>
       <p:sp>
         <p:nvSpPr>

</xml_diff>

<commit_message>
docs: the pen testing is past tense - the current role is the SOC
Reported by the presenter: "Penetration tester by trade" is wrong. He is
a former penetration tester and works in the SOC now, and the deck said
it four different ways across the slide, the notes, the run-of-show and
the 30-minute script.

The whoami now runs backwards through the actual chronology - the SOC
today, penetration testing before that, uniform before that - which also
sets up the line that follows it, that offensive work taught him the weak
link is the person. Slide 2's left column names the SOC, and the bullet
that read "Penetration tester background" now says "Former penetration
tester" so the tense is not left to the reader.

Spoken length goes 0:40 to 0:45 against a one-minute slot.

Co-Authored-By: Claude Opus 5 <noreply@anthropic.com>
Claude-Session: https://claude.ai/code/session_01Lx4dCiPgkqtC2b17GtDU6z
</commit_message>
<xml_diff>
--- a/docs/submissions/Phasmid_DEFCON_DemoLabs.pptx
+++ b/docs/submissions/Phasmid_DEFCON_DemoLabs.pptx
@@ -3809,7 +3809,7 @@
           <a:p>
             <a:r>
               <a:rPr b="0" sz="1700"/>
-              <a:t>[00:30 / 1:00] WHOAMI — 発話 0:40</a:t>
+              <a:t>[00:30 / 1:00] WHOAMI — 発話 0:45</a:t>
             </a:r>
             <a:endParaRPr lang="en-US" dirty="0"/>
           </a:p>
@@ -3870,13 +3870,149 @@
           <a:p>
             <a:r>
               <a:rPr b="0" sz="1700"/>
-              <a:t>Security research, and open-source tools.</a:t>
-            </a:r>
-          </a:p>
-          <a:p>
-            <a:r>
-              <a:rPr b="0" sz="1700"/>
-              <a:t>  セキュリティ </a:t>
+              <a:t>I work in the SOC. Defence, every day.</a:t>
+            </a:r>
+          </a:p>
+          <a:p>
+            <a:r>
+              <a:rPr b="0" sz="1700"/>
+              <a:t>  アイ ワーク イン ザ </a:t>
+            </a:r>
+            <a:r>
+              <a:rPr b="1" sz="1700"/>
+              <a:t>エス オー シー</a:t>
+            </a:r>
+            <a:r>
+              <a:rPr b="0" sz="1700"/>
+              <a:t>。 </a:t>
+            </a:r>
+            <a:r>
+              <a:rPr b="1" sz="1700"/>
+              <a:t>ディフェンス</a:t>
+            </a:r>
+            <a:r>
+              <a:rPr b="0" sz="1700"/>
+              <a:t>、 エヴリ デイ。</a:t>
+            </a:r>
+          </a:p>
+          <a:p>
+            <a:r>
+              <a:rPr b="0" sz="1700"/>
+              <a:t>Before that — a penetration tester. CISSP.</a:t>
+            </a:r>
+          </a:p>
+          <a:p>
+            <a:r>
+              <a:rPr b="0" sz="1700"/>
+              <a:t>  ビフォー ザット — ア </a:t>
+            </a:r>
+            <a:r>
+              <a:rPr b="1" sz="1700"/>
+              <a:t>ペネトレイション テスター</a:t>
+            </a:r>
+            <a:r>
+              <a:rPr b="0" sz="1700"/>
+              <a:t>。 シー アイ エス エス ピー。</a:t>
+            </a:r>
+          </a:p>
+          <a:p>
+            <a:r>
+              <a:rPr b="0" sz="1700"/>
+              <a:t>And before that, in uniform — a Japan Ground Self-Defense Force officer, in a cyber unit.</a:t>
+            </a:r>
+          </a:p>
+          <a:p>
+            <a:r>
+              <a:rPr b="0" sz="1700"/>
+              <a:t>  アンド ビフォー ザット、 イン </a:t>
+            </a:r>
+            <a:r>
+              <a:rPr b="1" sz="1700"/>
+              <a:t>ユニフォーム</a:t>
+            </a:r>
+            <a:r>
+              <a:rPr b="0" sz="1700"/>
+              <a:t> — ア ジャパン グラウンド セルフディフェンス フォース </a:t>
+            </a:r>
+            <a:r>
+              <a:rPr b="1" sz="1700"/>
+              <a:t>オフィサー</a:t>
+            </a:r>
+            <a:r>
+              <a:rPr b="0" sz="1700"/>
+              <a:t>、 イン ア サイバー ユニット。</a:t>
+            </a:r>
+          </a:p>
+          <a:p>
+            <a:r>
+              <a:rPr b="0" sz="1700"/>
+              <a:t>Offensive work taught me the weak link is the person, not the algorithm.</a:t>
+            </a:r>
+          </a:p>
+          <a:p>
+            <a:r>
+              <a:rPr b="0" sz="1700"/>
+              <a:t>  オフェンシヴ ワーク トート ミー ザ ウィーク リンク イズ ザ </a:t>
+            </a:r>
+            <a:r>
+              <a:rPr b="1" sz="1700"/>
+              <a:t>パーソン</a:t>
+            </a:r>
+            <a:r>
+              <a:rPr b="0" sz="1700"/>
+              <a:t>、 ナット ジ アルゴリズム。</a:t>
+            </a:r>
+          </a:p>
+          <a:p>
+            <a:r>
+              <a:rPr b="0" sz="1700"/>
+              <a:t>So I turn offensive experience into defensive tools.</a:t>
+            </a:r>
+          </a:p>
+          <a:p>
+            <a:r>
+              <a:rPr b="0" sz="1700"/>
+              <a:t>  ソウ アイ ターン オフェンシヴ エクスピアリエンス イントゥ </a:t>
+            </a:r>
+            <a:r>
+              <a:rPr b="1" sz="1700"/>
+              <a:t>ディフェンシヴ ツールズ</a:t>
+            </a:r>
+            <a:r>
+              <a:rPr b="0" sz="1700"/>
+              <a:t>。</a:t>
+            </a:r>
+          </a:p>
+          <a:p>
+            <a:r>
+              <a:rPr b="0" sz="1700"/>
+              <a:t>Deception. Delay. Coercion-aware design.</a:t>
+            </a:r>
+          </a:p>
+          <a:p>
+            <a:r>
+              <a:rPr b="0" sz="1700"/>
+              <a:t>  ディセプション。 ディレイ。 </a:t>
+            </a:r>
+            <a:r>
+              <a:rPr b="1" sz="1700"/>
+              <a:t>コアージョン アウェア デザイン</a:t>
+            </a:r>
+            <a:r>
+              <a:rPr b="0" sz="1700"/>
+              <a:t>。</a:t>
+            </a:r>
+          </a:p>
+          <a:p>
+            <a:r>
+              <a:rPr b="0" sz="1700"/>
+              <a:t>Alongside that — security research, and open-source tools.</a:t>
+            </a:r>
+          </a:p>
+          <a:p>
+            <a:r>
+              <a:rPr b="0" sz="1700"/>
+              <a:t>  アロングサイド ザット — セキュリティ </a:t>
             </a:r>
             <a:r>
               <a:rPr b="1" sz="1700"/>
@@ -3889,114 +4025,6 @@
             <a:r>
               <a:rPr b="1" sz="1700"/>
               <a:t>オープンソース ツールズ</a:t>
-            </a:r>
-            <a:r>
-              <a:rPr b="0" sz="1700"/>
-              <a:t>。</a:t>
-            </a:r>
-          </a:p>
-          <a:p>
-            <a:r>
-              <a:rPr b="0" sz="1700"/>
-              <a:t>Penetration tester by trade. CISSP.</a:t>
-            </a:r>
-          </a:p>
-          <a:p>
-            <a:r>
-              <a:rPr b="0" sz="1700"/>
-              <a:t>  ペネトレイション テスター バイ </a:t>
-            </a:r>
-            <a:r>
-              <a:rPr b="1" sz="1700"/>
-              <a:t>トレイド</a:t>
-            </a:r>
-            <a:r>
-              <a:rPr b="0" sz="1700"/>
-              <a:t>。 シー アイ エス エス ピー。</a:t>
-            </a:r>
-          </a:p>
-          <a:p>
-            <a:r>
-              <a:rPr b="0" sz="1700"/>
-              <a:t>And before that, I was in uniform — a Japan Ground Self-Defense Force officer, in a cyber unit.</a:t>
-            </a:r>
-          </a:p>
-          <a:p>
-            <a:r>
-              <a:rPr b="0" sz="1700"/>
-              <a:t>  アンド ビフォー ザット、 アイ ワズ イン </a:t>
-            </a:r>
-            <a:r>
-              <a:rPr b="1" sz="1700"/>
-              <a:t>ユニフォーム</a:t>
-            </a:r>
-            <a:r>
-              <a:rPr b="0" sz="1700"/>
-              <a:t> — ア ジャパン グラウンド セルフディフェンス フォース </a:t>
-            </a:r>
-            <a:r>
-              <a:rPr b="1" sz="1700"/>
-              <a:t>オフィサー</a:t>
-            </a:r>
-            <a:r>
-              <a:rPr b="0" sz="1700"/>
-              <a:t>、 イン ア サイバー ユニット。</a:t>
-            </a:r>
-          </a:p>
-          <a:p>
-            <a:r>
-              <a:rPr b="0" sz="1700"/>
-              <a:t>Offensive work taught me the weak link is the person, not the algorithm.</a:t>
-            </a:r>
-          </a:p>
-          <a:p>
-            <a:r>
-              <a:rPr b="0" sz="1700"/>
-              <a:t>  オフェンシヴ ワーク トート ミー ザ ウィーク リンク イズ ザ </a:t>
-            </a:r>
-            <a:r>
-              <a:rPr b="1" sz="1700"/>
-              <a:t>パーソン</a:t>
-            </a:r>
-            <a:r>
-              <a:rPr b="0" sz="1700"/>
-              <a:t>、 ナット ジ アルゴリズム。</a:t>
-            </a:r>
-          </a:p>
-          <a:p>
-            <a:r>
-              <a:rPr b="0" sz="1700"/>
-              <a:t>So I turn offensive experience into defensive tools.</a:t>
-            </a:r>
-          </a:p>
-          <a:p>
-            <a:r>
-              <a:rPr b="0" sz="1700"/>
-              <a:t>  ソウ アイ ターン オフェンシヴ エクスピアリエンス イントゥ </a:t>
-            </a:r>
-            <a:r>
-              <a:rPr b="1" sz="1700"/>
-              <a:t>ディフェンシヴ ツールズ</a:t>
-            </a:r>
-            <a:r>
-              <a:rPr b="0" sz="1700"/>
-              <a:t>。</a:t>
-            </a:r>
-          </a:p>
-          <a:p>
-            <a:r>
-              <a:rPr b="0" sz="1700"/>
-              <a:t>Deception. Delay. Coercion-aware design.</a:t>
-            </a:r>
-          </a:p>
-          <a:p>
-            <a:r>
-              <a:rPr b="0" sz="1700"/>
-              <a:t>  ディセプション。 ディレイ。 </a:t>
-            </a:r>
-            <a:r>
-              <a:rPr b="1" sz="1700"/>
-              <a:t>コアージョン アウェア デザイン</a:t>
             </a:r>
             <a:r>
               <a:rPr b="0" sz="1700"/>
@@ -21093,7 +21121,7 @@
                 <a:ea typeface="Calibri" pitchFamily="34" charset="-122"/>
                 <a:cs typeface="Calibri" pitchFamily="34" charset="-120"/>
               </a:rPr>
-              <a:t>Senior Engineer · Security Researcher</a:t>
+              <a:t>Senior Engineer, SOC · Security Researcher</a:t>
             </a:r>
             <a:endParaRPr lang="en-US" sz="1500" dirty="0"/>
           </a:p>
@@ -21418,7 +21446,7 @@
                 <a:ea typeface="Calibri" pitchFamily="34" charset="-122"/>
                 <a:cs typeface="Calibri" pitchFamily="34" charset="-120"/>
               </a:rPr>
-              <a:t>Penetration tester background · CISSP</a:t>
+              <a:t>Former penetration tester · CISSP</a:t>
             </a:r>
             <a:endParaRPr lang="en-US" sz="1800" dirty="0"/>
           </a:p>

</xml_diff>